<commit_message>
Point materials at the real repo URL
Co-Authored-By: Claude Fable 5.1 <noreply@anthropic.com>
</commit_message>
<xml_diff>
--- a/slides/devops-workshop.pptx
+++ b/slides/devops-workshop.pptx
@@ -149,14 +149,14 @@
   <p:extLst>
     <p:ext uri="{521415D9-36F7-43E2-AB2F-B90AF26B5E84}">
       <p14:sectionLst xmlns:p14="http://schemas.microsoft.com/office/powerpoint/2010/main">
-        <p14:section name="Intro" id="{248198a7-584f-e61e-93a7-9988453ec526}">
+        <p14:section name="Intro" id="{88a254d5-0c57-a913-7e5d-421132ef8c8e}">
           <p14:sldIdLst>
             <p14:sldId id="256"/>
             <p14:sldId id="257"/>
             <p14:sldId id="258"/>
           </p14:sldIdLst>
         </p14:section>
-        <p14:section name="Docker" id="{a899b303-aae2-a697-9366-9caeb392a9d4}">
+        <p14:section name="Docker" id="{1f018873-36f8-e21c-f6fb-17220833f924}">
           <p14:sldIdLst>
             <p14:sldId id="259"/>
             <p14:sldId id="260"/>
@@ -172,7 +172,7 @@
             <p14:sldId id="270"/>
           </p14:sldIdLst>
         </p14:section>
-        <p14:section name="Kubernetes" id="{a5b32987-9ffc-5b07-b005-241255f4ce86}">
+        <p14:section name="Kubernetes" id="{b24e7409-f649-65bf-44db-d27f5ee23f69}">
           <p14:sldIdLst>
             <p14:sldId id="271"/>
             <p14:sldId id="272"/>
@@ -191,7 +191,7 @@
             <p14:sldId id="285"/>
           </p14:sldIdLst>
         </p14:section>
-        <p14:section name="CI/CD" id="{1aa92228-2230-803e-5f5b-61d32e53fd3a}">
+        <p14:section name="CI/CD" id="{3e2f2b5d-dec2-d2b1-78ea-802ea952e5f7}">
           <p14:sldIdLst>
             <p14:sldId id="286"/>
             <p14:sldId id="287"/>
@@ -205,7 +205,7 @@
             <p14:sldId id="295"/>
           </p14:sldIdLst>
         </p14:section>
-        <p14:section name="Wrap-up" id="{0316050f-c803-6d76-4f24-c677437afeff}">
+        <p14:section name="Wrap-up" id="{63b9a17b-664e-2ba9-cc3c-1627fa104ab3}">
           <p14:sldIdLst>
             <p14:sldId id="296"/>
             <p14:sldId id="297"/>
@@ -5404,7 +5404,7 @@
       </p:pic>
       <p:sp>
         <p:nvSpPr>
-          <p:cNvPr id="8" name="box Repo + labs:  github.com/&lt;your-user&gt;/devops-workshop      →  Code ▸ Codespaces ▸ Create codespace"/>
+          <p:cNvPr id="8" name="box Repo + labs:  github.com/PhalakshaCG/devops-session-10-26      →  Code ▸ Codespaces ▸ Create codespace"/>
           <p:cNvSpPr/>
           <p:nvPr/>
         </p:nvSpPr>
@@ -5431,7 +5431,7 @@
       </p:sp>
       <p:sp>
         <p:nvSpPr>
-          <p:cNvPr id="9" name="box text Repo + labs:  github.com/&amp;lt;your-user&amp;gt;/devops-workshop      →  Code ▸ Codespaces ▸ Create codespace"/>
+          <p:cNvPr id="9" name="box text Repo + labs:  github.com/PhalakshaCG/devops-session-10-26      →  Code ▸ Codespaces ▸ Create codespace"/>
           <p:cNvSpPr txBox="1"/>
           <p:nvPr/>
         </p:nvSpPr>
@@ -5459,7 +5459,7 @@
                   <a:srgbClr val="E2E8F0"/>
                 </a:solidFill>
               </a:rPr>
-              <a:t>Repo + labs:  github.com/&lt;your-user&gt;/devops-workshop      →  Code ▸ Codespaces ▸ Create codespace</a:t>
+              <a:t>Repo + labs:  github.com/PhalakshaCG/devops-session-10-26      →  Code ▸ Codespaces ▸ Create codespace</a:t>
             </a:r>
             <a:endParaRPr lang="en-US" sz="1400" dirty="0"/>
           </a:p>

</xml_diff>